<commit_message>
#10 Update PAVEL_7_UCT_hackathon_2026.pptx with new content
</commit_message>
<xml_diff>
--- a/PAVEL_7_UCT_hackathon_2026.pptx
+++ b/PAVEL_7_UCT_hackathon_2026.pptx
@@ -5076,13 +5076,13 @@
   <p:clrMapOvr>
     <a:masterClrMapping/>
   </p:clrMapOvr>
-  <mc:AlternateContent xmlns:mc="http://schemas.openxmlformats.org/markup-compatibility/2006">
-    <mc:Choice xmlns:p14="http://schemas.microsoft.com/office/powerpoint/2010/main" Requires="p14">
+  <mc:AlternateContent xmlns:mc="http://schemas.openxmlformats.org/markup-compatibility/2006" xmlns:p14="http://schemas.microsoft.com/office/powerpoint/2010/main">
+    <mc:Choice Requires="p14">
       <p:transition spd="slow" p14:dur="3400">
         <p14:reveal/>
       </p:transition>
     </mc:Choice>
-    <mc:Fallback>
+    <mc:Fallback xmlns="">
       <p:transition spd="slow">
         <p:fade/>
       </p:transition>
@@ -6589,13 +6589,13 @@
   <p:clrMapOvr>
     <a:masterClrMapping/>
   </p:clrMapOvr>
-  <mc:AlternateContent xmlns:mc="http://schemas.openxmlformats.org/markup-compatibility/2006">
-    <mc:Choice xmlns:p14="http://schemas.microsoft.com/office/powerpoint/2010/main" Requires="p14">
+  <mc:AlternateContent xmlns:mc="http://schemas.openxmlformats.org/markup-compatibility/2006" xmlns:p14="http://schemas.microsoft.com/office/powerpoint/2010/main">
+    <mc:Choice Requires="p14">
       <p:transition spd="med" p14:dur="700">
         <p:fade/>
       </p:transition>
     </mc:Choice>
-    <mc:Fallback>
+    <mc:Fallback xmlns="">
       <p:transition spd="med">
         <p:fade/>
       </p:transition>
@@ -6861,38 +6861,6 @@
                 <a:schemeClr val="bg1"/>
               </a:buClr>
             </a:pPr>
-            <a:r>
-              <a:rPr lang="en" sz="1600" b="1" dirty="0">
-                <a:solidFill>
-                  <a:schemeClr val="lt1"/>
-                </a:solidFill>
-              </a:rPr>
-              <a:t>Impact:</a:t>
-            </a:r>
-          </a:p>
-          <a:p>
-            <a:pPr marL="285750" indent="-285750">
-              <a:buClr>
-                <a:schemeClr val="bg1"/>
-              </a:buClr>
-              <a:buFont typeface="Arial" panose="020B0604020202020204" pitchFamily="34" charset="0"/>
-              <a:buChar char="•"/>
-            </a:pPr>
-            <a:r>
-              <a:rPr lang="en" sz="1600" dirty="0">
-                <a:solidFill>
-                  <a:schemeClr val="lt1"/>
-                </a:solidFill>
-              </a:rPr>
-              <a:t>PavalPayments transforms subscriptions into fair, flexible, and inclusive payment experiences.</a:t>
-            </a:r>
-          </a:p>
-          <a:p>
-            <a:pPr>
-              <a:buClr>
-                <a:schemeClr val="bg1"/>
-              </a:buClr>
-            </a:pPr>
             <a:endParaRPr lang="en" sz="1600" dirty="0">
               <a:solidFill>
                 <a:schemeClr val="lt1"/>
@@ -6906,80 +6874,12 @@
               </a:buClr>
             </a:pPr>
             <a:r>
-              <a:rPr lang="en" sz="1600" b="1" dirty="0">
+              <a:rPr lang="en" sz="1600" dirty="0">
                 <a:solidFill>
                   <a:schemeClr val="lt1"/>
                 </a:solidFill>
               </a:rPr>
-              <a:t>Benefits:</a:t>
-            </a:r>
-          </a:p>
-          <a:p>
-            <a:pPr marL="285750" indent="-285750">
-              <a:buClr>
-                <a:schemeClr val="bg1"/>
-              </a:buClr>
-              <a:buFont typeface="Arial" panose="020B0604020202020204" pitchFamily="34" charset="0"/>
-              <a:buChar char="•"/>
-            </a:pPr>
-            <a:r>
-              <a:rPr lang="en" sz="1600" dirty="0">
-                <a:solidFill>
-                  <a:schemeClr val="lt1"/>
-                </a:solidFill>
-              </a:rPr>
-              <a:t>Reduced subscription waste </a:t>
-            </a:r>
-          </a:p>
-          <a:p>
-            <a:pPr marL="285750" indent="-285750">
-              <a:buClr>
-                <a:schemeClr val="bg1"/>
-              </a:buClr>
-              <a:buFont typeface="Arial" panose="020B0604020202020204" pitchFamily="34" charset="0"/>
-              <a:buChar char="•"/>
-            </a:pPr>
-            <a:r>
-              <a:rPr lang="en" sz="1600" dirty="0">
-                <a:solidFill>
-                  <a:schemeClr val="lt1"/>
-                </a:solidFill>
-              </a:rPr>
-              <a:t>Greater financial inclusion</a:t>
-            </a:r>
-          </a:p>
-          <a:p>
-            <a:pPr marL="285750" indent="-285750">
-              <a:buClr>
-                <a:schemeClr val="bg1"/>
-              </a:buClr>
-              <a:buFont typeface="Arial" panose="020B0604020202020204" pitchFamily="34" charset="0"/>
-              <a:buChar char="•"/>
-            </a:pPr>
-            <a:r>
-              <a:rPr lang="en" sz="1600" dirty="0">
-                <a:solidFill>
-                  <a:schemeClr val="lt1"/>
-                </a:solidFill>
-              </a:rPr>
-              <a:t>Transparent billing </a:t>
-            </a:r>
-          </a:p>
-          <a:p>
-            <a:pPr marL="285750" indent="-285750">
-              <a:buClr>
-                <a:schemeClr val="bg1"/>
-              </a:buClr>
-              <a:buFont typeface="Arial" panose="020B0604020202020204" pitchFamily="34" charset="0"/>
-              <a:buChar char="•"/>
-            </a:pPr>
-            <a:r>
-              <a:rPr lang="en" sz="1600" dirty="0">
-                <a:solidFill>
-                  <a:schemeClr val="lt1"/>
-                </a:solidFill>
-              </a:rPr>
-              <a:t>Increased accessibility</a:t>
+              <a:t>PavelPayments transforms subscriptions into fair, flexible, and inclusive payment experiences.</a:t>
             </a:r>
           </a:p>
           <a:p>

</xml_diff>